<commit_message>
Replace slide 10 with correctly-rotated axis projection
The original high-frequency plots showed x-pixel and y-pixel as separate
traces, implicitly treating x as "the" signal and y as "cross-coupling
noise" -- only valid if the actuator's axis is close to the camera's,
which it isn't (fitted angle sits around -150 to -172 degrees). Replaced
with displacement projected onto each frequency's own fitted motion
direction (x*cos(angle) + y*sin(angle)) -- the actual 1D displacement
along the axis the actuator really moves on.

Notable: even correctly rotated, the 10-20Hz traces still look noisy
rather than cleanly sinusoidal. Projecting onto the true axis maximizes
captured signal (matches the fitted magnitude exactly) but doesn't
reduce measurement noise -- reassuring confirmation that the earlier
"weak signal at 15-20Hz" read wasn't an artifact of looking at the wrong
axis split.

Co-Authored-By: Claude Sonnet 5 <noreply@anthropic.com>
</commit_message>
<xml_diff>
--- a/docs/session_results_2026-08-04.pptx
+++ b/docs/session_results_2026-08-04.pptx
@@ -3192,7 +3192,7 @@
         <p:spPr>
           <a:xfrm>
             <a:off x="548640" y="365760"/>
-            <a:ext cx="11064240" cy="640080"/>
+            <a:ext cx="11064240" cy="914400"/>
           </a:xfrm>
           <a:prstGeom prst="rect">
             <a:avLst/>
@@ -3216,11 +3216,23 @@
               <a:t>Pushing toward the 10-20Hz disturbance band</a:t>
             </a:r>
           </a:p>
+          <a:p>
+            <a:pPr>
+              <a:defRPr sz="1400">
+                <a:solidFill>
+                  <a:srgbClr val="52514E"/>
+                </a:solidFill>
+              </a:defRPr>
+            </a:pPr>
+            <a:r>
+              <a:t>Projected onto the actuator's fitted motion axis, not the camera's x/y axes</a:t>
+            </a:r>
+          </a:p>
         </p:txBody>
       </p:sp>
       <p:pic>
         <p:nvPicPr>
-          <p:cNvPr id="3" name="Picture 2" descr="sine_highfreq.png"/>
+          <p:cNvPr id="3" name="Picture 2" descr="sine_highfreq_rotated.png"/>
           <p:cNvPicPr>
             <a:picLocks noChangeAspect="1"/>
           </p:cNvPicPr>
@@ -3234,8 +3246,8 @@
         </p:blipFill>
         <p:spPr>
           <a:xfrm>
-            <a:off x="320040" y="1051560"/>
-            <a:ext cx="11521440" cy="6559465"/>
+            <a:off x="320040" y="1234440"/>
+            <a:ext cx="11521440" cy="6606377"/>
           </a:xfrm>
           <a:prstGeom prst="rect">
             <a:avLst/>

</xml_diff>

<commit_message>
Add X-axis amplifier data; dual DAC/volt scales; slide with counts/V and counts/A
X-axis readings came back clean (no outlier needed excluding) -- notably
its 10th value (.084V) lands almost exactly where the Y-axis trend
predicted its own excluded 11th point would have been, an independent
sanity check on that exclusion.

X axis: R^2=0.99999 (essentially perfectly linear), slope -0.000732
V/count, counts/V=-1365, counts/A=-3891 (2.85 ohm load).
Y axis: R^2=0.9971, slope -0.000784 V/count, counts/V=-1276,
counts/A=-3636.

Each voltage/power subplot now has a secondary top x-axis in volts
(computed from that axis's own fit) alongside the primary DAC-counts
axis, so the same plot reads directly in either unit.

Added a slide to docs/session_results_2026-08-04.pptx with the 2x2 plot
grid (voltage + power, both axes) and a summary table of R^2/counts-per-
volt/counts-per-amp.

Co-Authored-By: Claude Sonnet 5 <noreply@anthropic.com>
</commit_message>
<xml_diff>
--- a/docs/session_results_2026-08-04.pptx
+++ b/docs/session_results_2026-08-04.pptx
@@ -21,6 +21,7 @@
     <p:sldId id="269" r:id="rId20"/>
     <p:sldId id="270" r:id="rId21"/>
     <p:sldId id="271" r:id="rId22"/>
+    <p:sldId id="272" r:id="rId23"/>
   </p:sldIdLst>
   <p:sldSz cx="12191695" cy="6858000" type="screen4x3"/>
   <p:notesSz cx="6858000" cy="9144000"/>
@@ -4634,6 +4635,438 @@
             </a:pPr>
             <a:r>
               <a:t>•  Practical implication, not yet resolved: which amplitude regime matters depends on how large the actual beacon-wobble disturbance is in DAC-equivalent terms. If real disturbances are small, the controller may still fight this stiction effect in practice (possibly needing a small dither signal to stay unstuck) even though large-signal bandwidth looks much healthier than first measured.</a:t>
+            </a:r>
+          </a:p>
+        </p:txBody>
+      </p:sp>
+    </p:spTree>
+  </p:cSld>
+  <p:clrMapOvr>
+    <a:masterClrMapping/>
+  </p:clrMapOvr>
+</p:sld>
+</file>
+
+<file path=ppt/slides/slide17.xml><?xml version="1.0" encoding="utf-8"?>
+<p:sld xmlns:a="http://schemas.openxmlformats.org/drawingml/2006/main" xmlns:p="http://schemas.openxmlformats.org/presentationml/2006/main" xmlns:r="http://schemas.openxmlformats.org/officeDocument/2006/relationships">
+  <p:cSld>
+    <p:spTree>
+      <p:nvGrpSpPr>
+        <p:cNvPr id="1" name=""/>
+        <p:cNvGrpSpPr/>
+        <p:nvPr/>
+      </p:nvGrpSpPr>
+      <p:grpSpPr/>
+      <p:sp>
+        <p:nvSpPr>
+          <p:cNvPr id="2" name="TextBox 1"/>
+          <p:cNvSpPr txBox="1"/>
+          <p:nvPr/>
+        </p:nvSpPr>
+        <p:spPr>
+          <a:xfrm>
+            <a:off x="548640" y="365760"/>
+            <a:ext cx="11064240" cy="914400"/>
+          </a:xfrm>
+          <a:prstGeom prst="rect">
+            <a:avLst/>
+          </a:prstGeom>
+          <a:noFill/>
+        </p:spPr>
+        <p:txBody>
+          <a:bodyPr wrap="square">
+            <a:spAutoFit/>
+          </a:bodyPr>
+          <a:lstStyle/>
+          <a:p>
+            <a:pPr>
+              <a:defRPr sz="2800" b="1">
+                <a:solidFill>
+                  <a:srgbClr val="0B0B0B"/>
+                </a:solidFill>
+              </a:defRPr>
+            </a:pPr>
+            <a:r>
+              <a:t>FTA amplifier static calibration — both axes</a:t>
+            </a:r>
+          </a:p>
+          <a:p>
+            <a:pPr>
+              <a:defRPr sz="1400">
+                <a:solidFill>
+                  <a:srgbClr val="52514E"/>
+                </a:solidFill>
+              </a:defRPr>
+            </a:pPr>
+            <a:r>
+              <a:t>DAC counts ↔ amplifier output voltage, R=2.85Ω load</a:t>
+            </a:r>
+          </a:p>
+        </p:txBody>
+      </p:sp>
+      <p:pic>
+        <p:nvPicPr>
+          <p:cNvPr id="3" name="Picture 2" descr="fta_amp_voltage_calibration.png"/>
+          <p:cNvPicPr>
+            <a:picLocks noChangeAspect="1"/>
+          </p:cNvPicPr>
+          <p:nvPr/>
+        </p:nvPicPr>
+        <p:blipFill>
+          <a:blip r:embed="rId2"/>
+          <a:stretch>
+            <a:fillRect/>
+          </a:stretch>
+        </p:blipFill>
+        <p:spPr>
+          <a:xfrm>
+            <a:off x="2651760" y="1097280"/>
+            <a:ext cx="7507705" cy="5486400"/>
+          </a:xfrm>
+          <a:prstGeom prst="rect">
+            <a:avLst/>
+          </a:prstGeom>
+        </p:spPr>
+      </p:pic>
+      <p:graphicFrame>
+        <p:nvGraphicFramePr>
+          <p:cNvPr id="4" name="Table 3"/>
+          <p:cNvGraphicFramePr>
+            <a:graphicFrameLocks noGrp="1"/>
+          </p:cNvGraphicFramePr>
+          <p:nvPr/>
+        </p:nvGraphicFramePr>
+        <p:xfrm>
+          <a:off x="274320" y="1280160"/>
+          <a:ext cx="2286000" cy="1371600"/>
+        </p:xfrm>
+        <a:graphic>
+          <a:graphicData uri="http://schemas.openxmlformats.org/drawingml/2006/table">
+            <a:tbl>
+              <a:tblPr firstRow="1" bandRow="1">
+                <a:tableStyleId>{5C22544A-7EE6-4342-B048-85BDC9FD1C3A}</a:tableStyleId>
+              </a:tblPr>
+              <a:tblGrid>
+                <a:gridCol w="502920"/>
+                <a:gridCol w="594360"/>
+                <a:gridCol w="594360"/>
+                <a:gridCol w="594360"/>
+              </a:tblGrid>
+              <a:tr h="457200">
+                <a:tc>
+                  <a:txBody>
+                    <a:bodyPr/>
+                    <a:lstStyle/>
+                    <a:p>
+                      <a:pPr>
+                        <a:defRPr b="1" sz="1100">
+                          <a:solidFill>
+                            <a:srgbClr val="FFFFFF"/>
+                          </a:solidFill>
+                        </a:defRPr>
+                      </a:pPr>
+                    </a:p>
+                  </a:txBody>
+                  <a:tcPr>
+                    <a:solidFill>
+                      <a:srgbClr val="2A78D6"/>
+                    </a:solidFill>
+                  </a:tcPr>
+                </a:tc>
+                <a:tc>
+                  <a:txBody>
+                    <a:bodyPr/>
+                    <a:lstStyle/>
+                    <a:p>
+                      <a:pPr>
+                        <a:defRPr b="1" sz="1100">
+                          <a:solidFill>
+                            <a:srgbClr val="FFFFFF"/>
+                          </a:solidFill>
+                        </a:defRPr>
+                      </a:pPr>
+                      <a:r>
+                        <a:t>R²</a:t>
+                      </a:r>
+                    </a:p>
+                  </a:txBody>
+                  <a:tcPr>
+                    <a:solidFill>
+                      <a:srgbClr val="2A78D6"/>
+                    </a:solidFill>
+                  </a:tcPr>
+                </a:tc>
+                <a:tc>
+                  <a:txBody>
+                    <a:bodyPr/>
+                    <a:lstStyle/>
+                    <a:p>
+                      <a:pPr>
+                        <a:defRPr b="1" sz="1100">
+                          <a:solidFill>
+                            <a:srgbClr val="FFFFFF"/>
+                          </a:solidFill>
+                        </a:defRPr>
+                      </a:pPr>
+                      <a:r>
+                        <a:t>counts/V</a:t>
+                      </a:r>
+                    </a:p>
+                  </a:txBody>
+                  <a:tcPr>
+                    <a:solidFill>
+                      <a:srgbClr val="2A78D6"/>
+                    </a:solidFill>
+                  </a:tcPr>
+                </a:tc>
+                <a:tc>
+                  <a:txBody>
+                    <a:bodyPr/>
+                    <a:lstStyle/>
+                    <a:p>
+                      <a:pPr>
+                        <a:defRPr b="1" sz="1100">
+                          <a:solidFill>
+                            <a:srgbClr val="FFFFFF"/>
+                          </a:solidFill>
+                        </a:defRPr>
+                      </a:pPr>
+                      <a:r>
+                        <a:t>counts/A</a:t>
+                      </a:r>
+                    </a:p>
+                  </a:txBody>
+                  <a:tcPr>
+                    <a:solidFill>
+                      <a:srgbClr val="2A78D6"/>
+                    </a:solidFill>
+                  </a:tcPr>
+                </a:tc>
+              </a:tr>
+              <a:tr h="457200">
+                <a:tc>
+                  <a:txBody>
+                    <a:bodyPr/>
+                    <a:lstStyle/>
+                    <a:p>
+                      <a:pPr>
+                        <a:defRPr sz="1100">
+                          <a:solidFill>
+                            <a:srgbClr val="0B0B0B"/>
+                          </a:solidFill>
+                        </a:defRPr>
+                      </a:pPr>
+                      <a:r>
+                        <a:t>X</a:t>
+                      </a:r>
+                    </a:p>
+                  </a:txBody>
+                  <a:tcPr/>
+                </a:tc>
+                <a:tc>
+                  <a:txBody>
+                    <a:bodyPr/>
+                    <a:lstStyle/>
+                    <a:p>
+                      <a:pPr>
+                        <a:defRPr sz="1100">
+                          <a:solidFill>
+                            <a:srgbClr val="0B0B0B"/>
+                          </a:solidFill>
+                        </a:defRPr>
+                      </a:pPr>
+                      <a:r>
+                        <a:t>1.0000</a:t>
+                      </a:r>
+                    </a:p>
+                  </a:txBody>
+                  <a:tcPr/>
+                </a:tc>
+                <a:tc>
+                  <a:txBody>
+                    <a:bodyPr/>
+                    <a:lstStyle/>
+                    <a:p>
+                      <a:pPr>
+                        <a:defRPr sz="1100">
+                          <a:solidFill>
+                            <a:srgbClr val="0B0B0B"/>
+                          </a:solidFill>
+                        </a:defRPr>
+                      </a:pPr>
+                      <a:r>
+                        <a:t>-1365</a:t>
+                      </a:r>
+                    </a:p>
+                  </a:txBody>
+                  <a:tcPr/>
+                </a:tc>
+                <a:tc>
+                  <a:txBody>
+                    <a:bodyPr/>
+                    <a:lstStyle/>
+                    <a:p>
+                      <a:pPr>
+                        <a:defRPr sz="1100">
+                          <a:solidFill>
+                            <a:srgbClr val="0B0B0B"/>
+                          </a:solidFill>
+                        </a:defRPr>
+                      </a:pPr>
+                      <a:r>
+                        <a:t>-3891</a:t>
+                      </a:r>
+                    </a:p>
+                  </a:txBody>
+                  <a:tcPr/>
+                </a:tc>
+              </a:tr>
+              <a:tr h="457200">
+                <a:tc>
+                  <a:txBody>
+                    <a:bodyPr/>
+                    <a:lstStyle/>
+                    <a:p>
+                      <a:pPr>
+                        <a:defRPr sz="1100">
+                          <a:solidFill>
+                            <a:srgbClr val="0B0B0B"/>
+                          </a:solidFill>
+                        </a:defRPr>
+                      </a:pPr>
+                      <a:r>
+                        <a:t>Y</a:t>
+                      </a:r>
+                    </a:p>
+                  </a:txBody>
+                  <a:tcPr/>
+                </a:tc>
+                <a:tc>
+                  <a:txBody>
+                    <a:bodyPr/>
+                    <a:lstStyle/>
+                    <a:p>
+                      <a:pPr>
+                        <a:defRPr sz="1100">
+                          <a:solidFill>
+                            <a:srgbClr val="0B0B0B"/>
+                          </a:solidFill>
+                        </a:defRPr>
+                      </a:pPr>
+                      <a:r>
+                        <a:t>0.9971</a:t>
+                      </a:r>
+                    </a:p>
+                  </a:txBody>
+                  <a:tcPr/>
+                </a:tc>
+                <a:tc>
+                  <a:txBody>
+                    <a:bodyPr/>
+                    <a:lstStyle/>
+                    <a:p>
+                      <a:pPr>
+                        <a:defRPr sz="1100">
+                          <a:solidFill>
+                            <a:srgbClr val="0B0B0B"/>
+                          </a:solidFill>
+                        </a:defRPr>
+                      </a:pPr>
+                      <a:r>
+                        <a:t>-1276</a:t>
+                      </a:r>
+                    </a:p>
+                  </a:txBody>
+                  <a:tcPr/>
+                </a:tc>
+                <a:tc>
+                  <a:txBody>
+                    <a:bodyPr/>
+                    <a:lstStyle/>
+                    <a:p>
+                      <a:pPr>
+                        <a:defRPr sz="1100">
+                          <a:solidFill>
+                            <a:srgbClr val="0B0B0B"/>
+                          </a:solidFill>
+                        </a:defRPr>
+                      </a:pPr>
+                      <a:r>
+                        <a:t>-3636</a:t>
+                      </a:r>
+                    </a:p>
+                  </a:txBody>
+                  <a:tcPr/>
+                </a:tc>
+              </a:tr>
+            </a:tbl>
+          </a:graphicData>
+        </a:graphic>
+      </p:graphicFrame>
+      <p:sp>
+        <p:nvSpPr>
+          <p:cNvPr id="5" name="TextBox 4"/>
+          <p:cNvSpPr txBox="1"/>
+          <p:nvPr/>
+        </p:nvSpPr>
+        <p:spPr>
+          <a:xfrm>
+            <a:off x="250838208000" y="3595347648000"/>
+            <a:ext cx="2090318400000" cy="2424769344000"/>
+          </a:xfrm>
+          <a:prstGeom prst="rect">
+            <a:avLst/>
+          </a:prstGeom>
+          <a:noFill/>
+        </p:spPr>
+        <p:txBody>
+          <a:bodyPr wrap="square">
+            <a:spAutoFit/>
+          </a:bodyPr>
+          <a:lstStyle/>
+          <a:p>
+            <a:pPr>
+              <a:spcAft>
+                <a:spcPts val="1000"/>
+              </a:spcAft>
+              <a:defRPr sz="1150">
+                <a:solidFill>
+                  <a:srgbClr val="0B0B0B"/>
+                </a:solidFill>
+              </a:defRPr>
+            </a:pPr>
+            <a:r>
+              <a:t>•  Both axes are highly linear statically (R²=1.0000 X, 0.9971 Y) — no visible kink or dead-band across the full 200-4000 DAC range.</a:t>
+            </a:r>
+          </a:p>
+          <a:p>
+            <a:pPr>
+              <a:spcAft>
+                <a:spcPts val="1000"/>
+              </a:spcAft>
+              <a:defRPr sz="1150">
+                <a:solidFill>
+                  <a:srgbClr val="0B0B0B"/>
+                </a:solidFill>
+              </a:defRPr>
+            </a:pPr>
+            <a:r>
+              <a:t>•  counts/V and counts/A are negative because voltage decreases as DAC counts increase on both axes (same sign convention already established from the step-response/sine-tracking data).</a:t>
+            </a:r>
+          </a:p>
+          <a:p>
+            <a:pPr>
+              <a:spcAft>
+                <a:spcPts val="1000"/>
+              </a:spcAft>
+              <a:defRPr sz="1150">
+                <a:solidFill>
+                  <a:srgbClr val="0B0B0B"/>
+                </a:solidFill>
+              </a:defRPr>
+            </a:pPr>
+            <a:r>
+              <a:t>•  Complementary evidence for the sine-tracking amplitude-comparison finding: since the DAC/amp stage is this linear when swept slowly, the dynamic nonlinear threshold seen at 15-20Hz more likely lives in actuator mechanics or a frequency-dependent electrical effect, not simple DC nonlinearity here.</a:t>
             </a:r>
           </a:p>
         </p:txBody>

</xml_diff>

<commit_message>
Add travel-range analysis slide to the deck
Co-Authored-By: Claude Sonnet 5 <noreply@anthropic.com>
</commit_message>
<xml_diff>
--- a/docs/session_results_2026-08-04.pptx
+++ b/docs/session_results_2026-08-04.pptx
@@ -22,6 +22,7 @@
     <p:sldId id="270" r:id="rId21"/>
     <p:sldId id="271" r:id="rId22"/>
     <p:sldId id="272" r:id="rId23"/>
+    <p:sldId id="273" r:id="rId24"/>
   </p:sldIdLst>
   <p:sldSz cx="12191695" cy="6858000" type="screen4x3"/>
   <p:notesSz cx="6858000" cy="9144000"/>
@@ -5067,6 +5068,163 @@
             </a:pPr>
             <a:r>
               <a:t>•  Complementary evidence for the sine-tracking amplitude-comparison finding: since the DAC/amp stage is this linear when swept slowly, the dynamic nonlinear threshold seen at 15-20Hz more likely lives in actuator mechanics or a frequency-dependent electrical effect, not simple DC nonlinearity here.</a:t>
+            </a:r>
+          </a:p>
+        </p:txBody>
+      </p:sp>
+    </p:spTree>
+  </p:cSld>
+  <p:clrMapOvr>
+    <a:masterClrMapping/>
+  </p:clrMapOvr>
+</p:sld>
+</file>
+
+<file path=ppt/slides/slide18.xml><?xml version="1.0" encoding="utf-8"?>
+<p:sld xmlns:a="http://schemas.openxmlformats.org/drawingml/2006/main" xmlns:p="http://schemas.openxmlformats.org/presentationml/2006/main" xmlns:r="http://schemas.openxmlformats.org/officeDocument/2006/relationships">
+  <p:cSld>
+    <p:spTree>
+      <p:nvGrpSpPr>
+        <p:cNvPr id="1" name=""/>
+        <p:cNvGrpSpPr/>
+        <p:nvPr/>
+      </p:nvGrpSpPr>
+      <p:grpSpPr/>
+      <p:sp>
+        <p:nvSpPr>
+          <p:cNvPr id="2" name="TextBox 1"/>
+          <p:cNvSpPr txBox="1"/>
+          <p:nvPr/>
+        </p:nvSpPr>
+        <p:spPr>
+          <a:xfrm>
+            <a:off x="548640" y="365760"/>
+            <a:ext cx="11064240" cy="914400"/>
+          </a:xfrm>
+          <a:prstGeom prst="rect">
+            <a:avLst/>
+          </a:prstGeom>
+          <a:noFill/>
+        </p:spPr>
+        <p:txBody>
+          <a:bodyPr wrap="square">
+            <a:spAutoFit/>
+          </a:bodyPr>
+          <a:lstStyle/>
+          <a:p>
+            <a:pPr>
+              <a:defRPr sz="2800" b="1">
+                <a:solidFill>
+                  <a:srgbClr val="0B0B0B"/>
+                </a:solidFill>
+              </a:defRPr>
+            </a:pPr>
+            <a:r>
+              <a:t>Where does the centroid actually stop moving?</a:t>
+            </a:r>
+          </a:p>
+          <a:p>
+            <a:pPr>
+              <a:defRPr sz="1400">
+                <a:solidFill>
+                  <a:srgbClr val="52514E"/>
+                </a:solidFill>
+              </a:defRPr>
+            </a:pPr>
+            <a:r>
+              <a:t>Calibration sweep (DAC→centroid) combined with the amplifier power fit</a:t>
+            </a:r>
+          </a:p>
+        </p:txBody>
+      </p:sp>
+      <p:pic>
+        <p:nvPicPr>
+          <p:cNvPr id="3" name="Picture 2" descr="fta_travel_range_analysis.png"/>
+          <p:cNvPicPr>
+            <a:picLocks noChangeAspect="1"/>
+          </p:cNvPicPr>
+          <p:nvPr/>
+        </p:nvPicPr>
+        <p:blipFill>
+          <a:blip r:embed="rId2"/>
+          <a:stretch>
+            <a:fillRect/>
+          </a:stretch>
+        </p:blipFill>
+        <p:spPr>
+          <a:xfrm>
+            <a:off x="3337560" y="1188720"/>
+            <a:ext cx="5745479" cy="3977639"/>
+          </a:xfrm>
+          <a:prstGeom prst="rect">
+            <a:avLst/>
+          </a:prstGeom>
+        </p:spPr>
+      </p:pic>
+      <p:sp>
+        <p:nvSpPr>
+          <p:cNvPr id="4" name="TextBox 3"/>
+          <p:cNvSpPr txBox="1"/>
+          <p:nvPr/>
+        </p:nvSpPr>
+        <p:spPr>
+          <a:xfrm>
+            <a:off x="418063680000" y="4849538688000"/>
+            <a:ext cx="10284366528000" cy="1254191040000"/>
+          </a:xfrm>
+          <a:prstGeom prst="rect">
+            <a:avLst/>
+          </a:prstGeom>
+          <a:noFill/>
+        </p:spPr>
+        <p:txBody>
+          <a:bodyPr wrap="square">
+            <a:spAutoFit/>
+          </a:bodyPr>
+          <a:lstStyle/>
+          <a:p>
+            <a:pPr>
+              <a:spcAft>
+                <a:spcPts val="1000"/>
+              </a:spcAft>
+              <a:defRPr sz="1300">
+                <a:solidFill>
+                  <a:srgbClr val="0B0B0B"/>
+                </a:solidFill>
+              </a:defRPr>
+            </a:pPr>
+            <a:r>
+              <a:t>•  X axis: cx tracks dac_x linearly across the ENTIRE tested range (200-3800) — no flattening at either end, still responding right up to both extremes.</a:t>
+            </a:r>
+          </a:p>
+          <a:p>
+            <a:pPr>
+              <a:spcAft>
+                <a:spcPts val="1000"/>
+              </a:spcAft>
+              <a:defRPr sz="1300">
+                <a:solidFill>
+                  <a:srgbClr val="0B0B0B"/>
+                </a:solidFill>
+              </a:defRPr>
+            </a:pPr>
+            <a:r>
+              <a:t>•  Y axis: cy rises steeply from dac_y=200→~500 (~0.028 px/count), then flattens almost completely for the rest of the range 500-3800 (~0.003 mid-range, ~0.0015 at the high end — a 94-95% sensitivity drop) while power keeps climbing to ~850mW at the far end.</a:t>
+            </a:r>
+          </a:p>
+          <a:p>
+            <a:pPr>
+              <a:spcAft>
+                <a:spcPts val="1000"/>
+              </a:spcAft>
+              <a:defRPr sz="1300">
+                <a:solidFill>
+                  <a:srgbClr val="0B0B0B"/>
+                </a:solidFill>
+              </a:defRPr>
+            </a:pPr>
+            <a:r>
+              <a:t>•  Read: the Y axis's real useful travel is only about DAC 200-500/800 — a small fraction of what was swept. Past that, DAC-y commands spend power for essentially zero additional beam movement, consistent with hitting a real mechanical limit early.</a:t>
             </a:r>
           </a:p>
         </p:txBody>

</xml_diff>

<commit_message>
Add slide-10-style rotated trace plots at amplitude 400 and 800
Same DAC-command + true-motion-axis-projected displacement view as slide
10, reproduced for the two higher-amplitude sweeps already collected
(amplitude comparison, slides 15-16) but never shown at the per-frequency
trace level before -- only the aggregate magnitude/retention charts were
built for those. Fitted amplitude/lag numbers match what the amplitude
comparison already reported (e.g. amp=800: ~44-50px across 5-20Hz vs
amp=200's collapse to ~2.6-4px at 15-20Hz).

Co-Authored-By: Claude Sonnet 5 <noreply@anthropic.com>
</commit_message>
<xml_diff>
--- a/docs/session_results_2026-08-04.pptx
+++ b/docs/session_results_2026-08-04.pptx
@@ -23,6 +23,8 @@
     <p:sldId id="271" r:id="rId22"/>
     <p:sldId id="272" r:id="rId23"/>
     <p:sldId id="273" r:id="rId24"/>
+    <p:sldId id="274" r:id="rId25"/>
+    <p:sldId id="275" r:id="rId26"/>
   </p:sldIdLst>
   <p:sldSz cx="12191695" cy="6858000" type="screen4x3"/>
   <p:notesSz cx="6858000" cy="9144000"/>
@@ -5237,6 +5239,95 @@
 </p:sld>
 </file>
 
+<file path=ppt/slides/slide19.xml><?xml version="1.0" encoding="utf-8"?>
+<p:sld xmlns:a="http://schemas.openxmlformats.org/drawingml/2006/main" xmlns:p="http://schemas.openxmlformats.org/presentationml/2006/main" xmlns:r="http://schemas.openxmlformats.org/officeDocument/2006/relationships">
+  <p:cSld>
+    <p:spTree>
+      <p:nvGrpSpPr>
+        <p:cNvPr id="1" name=""/>
+        <p:cNvGrpSpPr/>
+        <p:nvPr/>
+      </p:nvGrpSpPr>
+      <p:grpSpPr/>
+      <p:sp>
+        <p:nvSpPr>
+          <p:cNvPr id="2" name="TextBox 1"/>
+          <p:cNvSpPr txBox="1"/>
+          <p:nvPr/>
+        </p:nvSpPr>
+        <p:spPr>
+          <a:xfrm>
+            <a:off x="548640" y="365760"/>
+            <a:ext cx="11064240" cy="914400"/>
+          </a:xfrm>
+          <a:prstGeom prst="rect">
+            <a:avLst/>
+          </a:prstGeom>
+          <a:noFill/>
+        </p:spPr>
+        <p:txBody>
+          <a:bodyPr wrap="square">
+            <a:spAutoFit/>
+          </a:bodyPr>
+          <a:lstStyle/>
+          <a:p>
+            <a:pPr>
+              <a:defRPr sz="2800" b="1">
+                <a:solidFill>
+                  <a:srgbClr val="0B0B0B"/>
+                </a:solidFill>
+              </a:defRPr>
+            </a:pPr>
+            <a:r>
+              <a:t>Same view as slide 10, at ±400 DAC counts</a:t>
+            </a:r>
+          </a:p>
+          <a:p>
+            <a:pPr>
+              <a:defRPr sz="1400">
+                <a:solidFill>
+                  <a:srgbClr val="52514E"/>
+                </a:solidFill>
+              </a:defRPr>
+            </a:pPr>
+            <a:r>
+              <a:t>Projected onto the actuator's fitted motion axis, not the camera's x/y axes</a:t>
+            </a:r>
+          </a:p>
+        </p:txBody>
+      </p:sp>
+      <p:pic>
+        <p:nvPicPr>
+          <p:cNvPr id="3" name="Picture 2" descr="sine_highfreq_rotated_amp400.png"/>
+          <p:cNvPicPr>
+            <a:picLocks noChangeAspect="1"/>
+          </p:cNvPicPr>
+          <p:nvPr/>
+        </p:nvPicPr>
+        <p:blipFill>
+          <a:blip r:embed="rId2"/>
+          <a:stretch>
+            <a:fillRect/>
+          </a:stretch>
+        </p:blipFill>
+        <p:spPr>
+          <a:xfrm>
+            <a:off x="320040" y="1234440"/>
+            <a:ext cx="11521440" cy="6606377"/>
+          </a:xfrm>
+          <a:prstGeom prst="rect">
+            <a:avLst/>
+          </a:prstGeom>
+        </p:spPr>
+      </p:pic>
+    </p:spTree>
+  </p:cSld>
+  <p:clrMapOvr>
+    <a:masterClrMapping/>
+  </p:clrMapOvr>
+</p:sld>
+</file>
+
 <file path=ppt/slides/slide2.xml><?xml version="1.0" encoding="utf-8"?>
 <p:sld xmlns:a="http://schemas.openxmlformats.org/drawingml/2006/main" xmlns:p="http://schemas.openxmlformats.org/presentationml/2006/main" xmlns:r="http://schemas.openxmlformats.org/officeDocument/2006/relationships">
   <p:cSld>
@@ -5380,6 +5471,95 @@
           </a:p>
         </p:txBody>
       </p:sp>
+    </p:spTree>
+  </p:cSld>
+  <p:clrMapOvr>
+    <a:masterClrMapping/>
+  </p:clrMapOvr>
+</p:sld>
+</file>
+
+<file path=ppt/slides/slide20.xml><?xml version="1.0" encoding="utf-8"?>
+<p:sld xmlns:a="http://schemas.openxmlformats.org/drawingml/2006/main" xmlns:p="http://schemas.openxmlformats.org/presentationml/2006/main" xmlns:r="http://schemas.openxmlformats.org/officeDocument/2006/relationships">
+  <p:cSld>
+    <p:spTree>
+      <p:nvGrpSpPr>
+        <p:cNvPr id="1" name=""/>
+        <p:cNvGrpSpPr/>
+        <p:nvPr/>
+      </p:nvGrpSpPr>
+      <p:grpSpPr/>
+      <p:sp>
+        <p:nvSpPr>
+          <p:cNvPr id="2" name="TextBox 1"/>
+          <p:cNvSpPr txBox="1"/>
+          <p:nvPr/>
+        </p:nvSpPr>
+        <p:spPr>
+          <a:xfrm>
+            <a:off x="548640" y="365760"/>
+            <a:ext cx="11064240" cy="914400"/>
+          </a:xfrm>
+          <a:prstGeom prst="rect">
+            <a:avLst/>
+          </a:prstGeom>
+          <a:noFill/>
+        </p:spPr>
+        <p:txBody>
+          <a:bodyPr wrap="square">
+            <a:spAutoFit/>
+          </a:bodyPr>
+          <a:lstStyle/>
+          <a:p>
+            <a:pPr>
+              <a:defRPr sz="2800" b="1">
+                <a:solidFill>
+                  <a:srgbClr val="0B0B0B"/>
+                </a:solidFill>
+              </a:defRPr>
+            </a:pPr>
+            <a:r>
+              <a:t>Same view as slide 10, at ±800 DAC counts</a:t>
+            </a:r>
+          </a:p>
+          <a:p>
+            <a:pPr>
+              <a:defRPr sz="1400">
+                <a:solidFill>
+                  <a:srgbClr val="52514E"/>
+                </a:solidFill>
+              </a:defRPr>
+            </a:pPr>
+            <a:r>
+              <a:t>Projected onto the actuator's fitted motion axis, not the camera's x/y axes</a:t>
+            </a:r>
+          </a:p>
+        </p:txBody>
+      </p:sp>
+      <p:pic>
+        <p:nvPicPr>
+          <p:cNvPr id="3" name="Picture 2" descr="sine_highfreq_rotated_amp800.png"/>
+          <p:cNvPicPr>
+            <a:picLocks noChangeAspect="1"/>
+          </p:cNvPicPr>
+          <p:nvPr/>
+        </p:nvPicPr>
+        <p:blipFill>
+          <a:blip r:embed="rId2"/>
+          <a:stretch>
+            <a:fillRect/>
+          </a:stretch>
+        </p:blipFill>
+        <p:spPr>
+          <a:xfrm>
+            <a:off x="320040" y="1234440"/>
+            <a:ext cx="11521440" cy="6606377"/>
+          </a:xfrm>
+          <a:prstGeom prst="rect">
+            <a:avLst/>
+          </a:prstGeom>
+        </p:spPr>
+      </p:pic>
     </p:spTree>
   </p:cSld>
   <p:clrMapOvr>

</xml_diff>